<commit_message>
Replace fake placeholder chart with real growth chart; add deck PDF
Slide 8's chart was a Canva AI-generated placeholder — it carried a visible
"Source: AI-generated data. Replace or verify before use" caption and
fabricated metrics (Day-7 retention, words solved per session) we never
measured. Replaced it with a real cumulative "Verified testnet users over
time" chart built from the on-chain verification data (rises to 51,
sourced to Stellar Horizon / WALLET_VERIFICATION.md), styled to match the
deck theme.

Also exported the finalized deck to PDF (Pitch Deck/Word_Scramble_Pitch_Deck.pdf)
and linked both PPTX and PDF from the README Product Presentation section.
Verified all 9 slides render without text overflow.
</commit_message>
<xml_diff>
--- a/Pitch Deck/Word_Scramble_Pitch_Deck.pptx
+++ b/Pitch Deck/Word_Scramble_Pitch_Deck.pptx
@@ -8756,30 +8756,6 @@
           <a:chExt cx="0" cy="0"/>
         </a:xfrm>
       </p:grpSpPr>
-      <p:pic>
-        <p:nvPicPr>
-          <p:cNvPr name="Picture 2" id="2"/>
-          <p:cNvPicPr>
-            <a:picLocks noChangeAspect="true"/>
-          </p:cNvPicPr>
-          <p:nvPr/>
-        </p:nvPicPr>
-        <p:blipFill>
-          <a:blip r:embed="rId2"/>
-          <a:stretch>
-            <a:fillRect/>
-          </a:stretch>
-        </p:blipFill>
-        <p:spPr>
-          <a:xfrm rot="0">
-            <a:off x="9878325" y="114300"/>
-            <a:ext cx="8287383" cy="10058400"/>
-          </a:xfrm>
-          <a:prstGeom prst="rect">
-            <a:avLst/>
-          </a:prstGeom>
-        </p:spPr>
-      </p:pic>
       <p:grpSp>
         <p:nvGrpSpPr>
           <p:cNvPr name="Group 3" id="3"/>
@@ -9050,6 +9026,30 @@
           </p:txBody>
         </p:sp>
       </p:grpSp>
+      <p:pic>
+        <p:nvPicPr>
+          <p:cNvPr id="10" name="Picture 9" descr="growth_chart.png"/>
+          <p:cNvPicPr>
+            <a:picLocks noChangeAspect="1"/>
+          </p:cNvPicPr>
+          <p:nvPr/>
+        </p:nvPicPr>
+        <p:blipFill>
+          <a:blip r:embed="rId4"/>
+          <a:stretch>
+            <a:fillRect/>
+          </a:stretch>
+        </p:blipFill>
+        <p:spPr>
+          <a:xfrm>
+            <a:off x="9966960" y="2645912"/>
+            <a:ext cx="7955279" cy="4995175"/>
+          </a:xfrm>
+          <a:prstGeom prst="rect">
+            <a:avLst/>
+          </a:prstGeom>
+        </p:spPr>
+      </p:pic>
     </p:spTree>
   </p:cSld>
   <p:clrMapOvr>

</xml_diff>